<commit_message>
Add Cs2CO3 to the slide descriptors (PBE0 q and E_b split computed)
Co-Authored-By: Claude Opus 5.5 <noreply@anthropic.com>
Claude-Session: https://claude.ai/code/session_01QdGePAvo7ESgQUdueHRqPN
</commit_message>
<xml_diff>
--- a/dft_seedlayer_screen/slides/seed_screening_2p.pptx
+++ b/dft_seedlayer_screen/slides/seed_screening_2p.pptx
@@ -206,9 +206,9 @@
           </c:dLbls>
           <c:cat>
             <c:multiLvlStrRef>
-              <c:f>Sheet1!$A$2:$A$20</c:f>
+              <c:f>Sheet1!$A$2:$A$21</c:f>
               <c:multiLvlStrCache>
-                <c:ptCount val="19"/>
+                <c:ptCount val="20"/>
                 <c:lvl>
                   <c:pt idx="0">
                     <c:v>NPB  0.25</c:v>
@@ -256,15 +256,18 @@
                     <c:v>Bphen  0.62</c:v>
                   </c:pt>
                   <c:pt idx="15">
+                    <c:v>Cs₂CO₃  0.70</c:v>
+                  </c:pt>
+                  <c:pt idx="16">
                     <c:v>p-bPPhenB  0.79</c:v>
                   </c:pt>
-                  <c:pt idx="16">
+                  <c:pt idx="17">
                     <c:v>F6-TCNNQ  1.20</c:v>
                   </c:pt>
-                  <c:pt idx="17">
+                  <c:pt idx="18">
                     <c:v>F4TCNQ  1.21</c:v>
                   </c:pt>
-                  <c:pt idx="18">
+                  <c:pt idx="19">
                     <c:v>HATCN  1.63</c:v>
                   </c:pt>
                 </c:lvl>
@@ -273,10 +276,10 @@
           </c:cat>
           <c:val>
             <c:numRef>
-              <c:f>Sheet1!$B$2:$B$20</c:f>
+              <c:f>Sheet1!$B$2:$B$21</c:f>
               <c:numCache>
                 <c:formatCode>General</c:formatCode>
-                <c:ptCount val="19"/>
+                <c:ptCount val="20"/>
                 <c:pt idx="0">
                   <c:v>0</c:v>
                 </c:pt>
@@ -323,15 +326,18 @@
                   <c:v>0.475</c:v>
                 </c:pt>
                 <c:pt idx="15">
+                  <c:v>0.609</c:v>
+                </c:pt>
+                <c:pt idx="16">
                   <c:v>0.589</c:v>
                 </c:pt>
-                <c:pt idx="16">
+                <c:pt idx="17">
                   <c:v>1.105</c:v>
                 </c:pt>
-                <c:pt idx="17">
+                <c:pt idx="18">
                   <c:v>1.147</c:v>
                 </c:pt>
-                <c:pt idx="18">
+                <c:pt idx="19">
                   <c:v>1.456</c:v>
                 </c:pt>
               </c:numCache>
@@ -385,9 +391,9 @@
           </c:dLbls>
           <c:cat>
             <c:multiLvlStrRef>
-              <c:f>Sheet1!$A$2:$A$20</c:f>
+              <c:f>Sheet1!$A$2:$A$21</c:f>
               <c:multiLvlStrCache>
-                <c:ptCount val="19"/>
+                <c:ptCount val="20"/>
                 <c:lvl>
                   <c:pt idx="0">
                     <c:v>NPB  0.25</c:v>
@@ -435,15 +441,18 @@
                     <c:v>Bphen  0.62</c:v>
                   </c:pt>
                   <c:pt idx="15">
+                    <c:v>Cs₂CO₃  0.70</c:v>
+                  </c:pt>
+                  <c:pt idx="16">
                     <c:v>p-bPPhenB  0.79</c:v>
                   </c:pt>
-                  <c:pt idx="16">
+                  <c:pt idx="17">
                     <c:v>F6-TCNNQ  1.20</c:v>
                   </c:pt>
-                  <c:pt idx="17">
+                  <c:pt idx="18">
                     <c:v>F4TCNQ  1.21</c:v>
                   </c:pt>
-                  <c:pt idx="18">
+                  <c:pt idx="19">
                     <c:v>HATCN  1.63</c:v>
                   </c:pt>
                 </c:lvl>
@@ -452,10 +461,10 @@
           </c:cat>
           <c:val>
             <c:numRef>
-              <c:f>Sheet1!$C$2:$C$20</c:f>
+              <c:f>Sheet1!$C$2:$C$21</c:f>
               <c:numCache>
                 <c:formatCode>General</c:formatCode>
-                <c:ptCount val="19"/>
+                <c:ptCount val="20"/>
                 <c:pt idx="0">
                   <c:v>0.258</c:v>
                 </c:pt>
@@ -502,15 +511,18 @@
                   <c:v>0.134</c:v>
                 </c:pt>
                 <c:pt idx="15">
+                  <c:v>0.091</c:v>
+                </c:pt>
+                <c:pt idx="16">
                   <c:v>0.195</c:v>
                 </c:pt>
-                <c:pt idx="16">
+                <c:pt idx="17">
                   <c:v>0.097</c:v>
                 </c:pt>
-                <c:pt idx="17">
+                <c:pt idx="18">
                   <c:v>0.061</c:v>
                 </c:pt>
-                <c:pt idx="18">
+                <c:pt idx="19">
                   <c:v>0.175</c:v>
                 </c:pt>
               </c:numCache>
@@ -779,9 +791,9 @@
           </c:dLbls>
           <c:cat>
             <c:multiLvlStrRef>
-              <c:f>Sheet1!$A$2:$A$20</c:f>
+              <c:f>Sheet1!$A$2:$A$21</c:f>
               <c:multiLvlStrCache>
-                <c:ptCount val="19"/>
+                <c:ptCount val="20"/>
                 <c:lvl>
                   <c:pt idx="0">
                     <c:v>TmPyPB</c:v>
@@ -793,51 +805,54 @@
                     <c:v>3TPYMB</c:v>
                   </c:pt>
                   <c:pt idx="3">
+                    <c:v>Cs₂CO₃</c:v>
+                  </c:pt>
+                  <c:pt idx="4">
                     <c:v>DPEPO</c:v>
                   </c:pt>
-                  <c:pt idx="4">
+                  <c:pt idx="5">
                     <c:v>TSPO1</c:v>
                   </c:pt>
-                  <c:pt idx="5">
+                  <c:pt idx="6">
                     <c:v>Liq</c:v>
                   </c:pt>
-                  <c:pt idx="6">
+                  <c:pt idx="7">
                     <c:v>Alq3</c:v>
                   </c:pt>
-                  <c:pt idx="7">
+                  <c:pt idx="8">
                     <c:v>Bphen</c:v>
                   </c:pt>
-                  <c:pt idx="8">
+                  <c:pt idx="9">
                     <c:v>BCP</c:v>
                   </c:pt>
-                  <c:pt idx="9">
+                  <c:pt idx="10">
                     <c:v>PO-T2T</c:v>
                   </c:pt>
-                  <c:pt idx="10">
+                  <c:pt idx="11">
                     <c:v>B3PyMPM</c:v>
                   </c:pt>
-                  <c:pt idx="11">
+                  <c:pt idx="12">
                     <c:v>NPB</c:v>
                   </c:pt>
-                  <c:pt idx="12">
+                  <c:pt idx="13">
                     <c:v>T2T</c:v>
                   </c:pt>
-                  <c:pt idx="13">
+                  <c:pt idx="14">
                     <c:v>mCP</c:v>
                   </c:pt>
-                  <c:pt idx="14">
+                  <c:pt idx="15">
                     <c:v>NBphen</c:v>
                   </c:pt>
-                  <c:pt idx="15">
+                  <c:pt idx="16">
                     <c:v>p-bPPhenB</c:v>
                   </c:pt>
-                  <c:pt idx="16">
+                  <c:pt idx="17">
                     <c:v>F4TCNQ</c:v>
                   </c:pt>
-                  <c:pt idx="17">
+                  <c:pt idx="18">
                     <c:v>HATCN</c:v>
                   </c:pt>
-                  <c:pt idx="18">
+                  <c:pt idx="19">
                     <c:v>F6-TCNNQ</c:v>
                   </c:pt>
                 </c:lvl>
@@ -846,10 +861,10 @@
           </c:cat>
           <c:val>
             <c:numRef>
-              <c:f>Sheet1!$B$2:$B$20</c:f>
+              <c:f>Sheet1!$B$2:$B$21</c:f>
               <c:numCache>
                 <c:formatCode>General</c:formatCode>
-                <c:ptCount val="19"/>
+                <c:ptCount val="20"/>
                 <c:pt idx="0">
                   <c:v>0</c:v>
                 </c:pt>
@@ -899,12 +914,15 @@
                   <c:v>0</c:v>
                 </c:pt>
                 <c:pt idx="16">
+                  <c:v>0</c:v>
+                </c:pt>
+                <c:pt idx="17">
                   <c:v>0.545</c:v>
                 </c:pt>
-                <c:pt idx="17">
+                <c:pt idx="18">
                   <c:v>0.572</c:v>
                 </c:pt>
-                <c:pt idx="18">
+                <c:pt idx="19">
                   <c:v>0.638</c:v>
                 </c:pt>
               </c:numCache>
@@ -958,9 +976,9 @@
           </c:dLbls>
           <c:cat>
             <c:multiLvlStrRef>
-              <c:f>Sheet1!$A$2:$A$20</c:f>
+              <c:f>Sheet1!$A$2:$A$21</c:f>
               <c:multiLvlStrCache>
-                <c:ptCount val="19"/>
+                <c:ptCount val="20"/>
                 <c:lvl>
                   <c:pt idx="0">
                     <c:v>TmPyPB</c:v>
@@ -972,51 +990,54 @@
                     <c:v>3TPYMB</c:v>
                   </c:pt>
                   <c:pt idx="3">
+                    <c:v>Cs₂CO₃</c:v>
+                  </c:pt>
+                  <c:pt idx="4">
                     <c:v>DPEPO</c:v>
                   </c:pt>
-                  <c:pt idx="4">
+                  <c:pt idx="5">
                     <c:v>TSPO1</c:v>
                   </c:pt>
-                  <c:pt idx="5">
+                  <c:pt idx="6">
                     <c:v>Liq</c:v>
                   </c:pt>
-                  <c:pt idx="6">
+                  <c:pt idx="7">
                     <c:v>Alq3</c:v>
                   </c:pt>
-                  <c:pt idx="7">
+                  <c:pt idx="8">
                     <c:v>Bphen</c:v>
                   </c:pt>
-                  <c:pt idx="8">
+                  <c:pt idx="9">
                     <c:v>BCP</c:v>
                   </c:pt>
-                  <c:pt idx="9">
+                  <c:pt idx="10">
                     <c:v>PO-T2T</c:v>
                   </c:pt>
-                  <c:pt idx="10">
+                  <c:pt idx="11">
                     <c:v>B3PyMPM</c:v>
                   </c:pt>
-                  <c:pt idx="11">
+                  <c:pt idx="12">
                     <c:v>NPB</c:v>
                   </c:pt>
-                  <c:pt idx="12">
+                  <c:pt idx="13">
                     <c:v>T2T</c:v>
                   </c:pt>
-                  <c:pt idx="13">
+                  <c:pt idx="14">
                     <c:v>mCP</c:v>
                   </c:pt>
-                  <c:pt idx="14">
+                  <c:pt idx="15">
                     <c:v>NBphen</c:v>
                   </c:pt>
-                  <c:pt idx="15">
+                  <c:pt idx="16">
                     <c:v>p-bPPhenB</c:v>
                   </c:pt>
-                  <c:pt idx="16">
+                  <c:pt idx="17">
                     <c:v>F4TCNQ</c:v>
                   </c:pt>
-                  <c:pt idx="17">
+                  <c:pt idx="18">
                     <c:v>HATCN</c:v>
                   </c:pt>
-                  <c:pt idx="18">
+                  <c:pt idx="19">
                     <c:v>F6-TCNNQ</c:v>
                   </c:pt>
                 </c:lvl>
@@ -1025,10 +1046,10 @@
           </c:cat>
           <c:val>
             <c:numRef>
-              <c:f>Sheet1!$C$2:$C$20</c:f>
+              <c:f>Sheet1!$C$2:$C$21</c:f>
               <c:numCache>
                 <c:formatCode>General</c:formatCode>
-                <c:ptCount val="19"/>
+                <c:ptCount val="20"/>
                 <c:pt idx="0">
                   <c:v>-0.116</c:v>
                 </c:pt>
@@ -1039,51 +1060,54 @@
                   <c:v>-0.115</c:v>
                 </c:pt>
                 <c:pt idx="3">
-                  <c:v>0</c:v>
+                  <c:v>-0.112</c:v>
                 </c:pt>
                 <c:pt idx="4">
                   <c:v>0</c:v>
                 </c:pt>
                 <c:pt idx="5">
+                  <c:v>0</c:v>
+                </c:pt>
+                <c:pt idx="6">
                   <c:v>-0.104</c:v>
                 </c:pt>
-                <c:pt idx="6">
+                <c:pt idx="7">
                   <c:v>-0.088</c:v>
                 </c:pt>
-                <c:pt idx="7">
+                <c:pt idx="8">
                   <c:v>-0.085</c:v>
                 </c:pt>
-                <c:pt idx="8">
+                <c:pt idx="9">
                   <c:v>-0.078</c:v>
                 </c:pt>
-                <c:pt idx="9">
+                <c:pt idx="10">
                   <c:v>-0.075</c:v>
                 </c:pt>
-                <c:pt idx="10">
+                <c:pt idx="11">
                   <c:v>-0.071</c:v>
                 </c:pt>
-                <c:pt idx="11">
-                  <c:v>0</c:v>
-                </c:pt>
                 <c:pt idx="12">
+                  <c:v>0</c:v>
+                </c:pt>
+                <c:pt idx="13">
                   <c:v>-0.045</c:v>
                 </c:pt>
-                <c:pt idx="13">
-                  <c:v>0</c:v>
-                </c:pt>
                 <c:pt idx="14">
+                  <c:v>0</c:v>
+                </c:pt>
+                <c:pt idx="15">
                   <c:v>-0.005</c:v>
                 </c:pt>
-                <c:pt idx="15">
+                <c:pt idx="16">
                   <c:v>0.148</c:v>
                 </c:pt>
-                <c:pt idx="16">
-                  <c:v>0</c:v>
-                </c:pt>
                 <c:pt idx="17">
                   <c:v>0</c:v>
                 </c:pt>
                 <c:pt idx="18">
+                  <c:v>0</c:v>
+                </c:pt>
+                <c:pt idx="19">
                   <c:v>0</c:v>
                 </c:pt>
               </c:numCache>
@@ -1137,9 +1161,9 @@
           </c:dLbls>
           <c:cat>
             <c:multiLvlStrRef>
-              <c:f>Sheet1!$A$2:$A$20</c:f>
+              <c:f>Sheet1!$A$2:$A$21</c:f>
               <c:multiLvlStrCache>
-                <c:ptCount val="19"/>
+                <c:ptCount val="20"/>
                 <c:lvl>
                   <c:pt idx="0">
                     <c:v>TmPyPB</c:v>
@@ -1151,51 +1175,54 @@
                     <c:v>3TPYMB</c:v>
                   </c:pt>
                   <c:pt idx="3">
+                    <c:v>Cs₂CO₃</c:v>
+                  </c:pt>
+                  <c:pt idx="4">
                     <c:v>DPEPO</c:v>
                   </c:pt>
-                  <c:pt idx="4">
+                  <c:pt idx="5">
                     <c:v>TSPO1</c:v>
                   </c:pt>
-                  <c:pt idx="5">
+                  <c:pt idx="6">
                     <c:v>Liq</c:v>
                   </c:pt>
-                  <c:pt idx="6">
+                  <c:pt idx="7">
                     <c:v>Alq3</c:v>
                   </c:pt>
-                  <c:pt idx="7">
+                  <c:pt idx="8">
                     <c:v>Bphen</c:v>
                   </c:pt>
-                  <c:pt idx="8">
+                  <c:pt idx="9">
                     <c:v>BCP</c:v>
                   </c:pt>
-                  <c:pt idx="9">
+                  <c:pt idx="10">
                     <c:v>PO-T2T</c:v>
                   </c:pt>
-                  <c:pt idx="10">
+                  <c:pt idx="11">
                     <c:v>B3PyMPM</c:v>
                   </c:pt>
-                  <c:pt idx="11">
+                  <c:pt idx="12">
                     <c:v>NPB</c:v>
                   </c:pt>
-                  <c:pt idx="12">
+                  <c:pt idx="13">
                     <c:v>T2T</c:v>
                   </c:pt>
-                  <c:pt idx="13">
+                  <c:pt idx="14">
                     <c:v>mCP</c:v>
                   </c:pt>
-                  <c:pt idx="14">
+                  <c:pt idx="15">
                     <c:v>NBphen</c:v>
                   </c:pt>
-                  <c:pt idx="15">
+                  <c:pt idx="16">
                     <c:v>p-bPPhenB</c:v>
                   </c:pt>
-                  <c:pt idx="16">
+                  <c:pt idx="17">
                     <c:v>F4TCNQ</c:v>
                   </c:pt>
-                  <c:pt idx="17">
+                  <c:pt idx="18">
                     <c:v>HATCN</c:v>
                   </c:pt>
-                  <c:pt idx="18">
+                  <c:pt idx="19">
                     <c:v>F6-TCNNQ</c:v>
                   </c:pt>
                 </c:lvl>
@@ -1204,10 +1231,10 @@
           </c:cat>
           <c:val>
             <c:numRef>
-              <c:f>Sheet1!$D$2:$D$20</c:f>
+              <c:f>Sheet1!$D$2:$D$21</c:f>
               <c:numCache>
                 <c:formatCode>General</c:formatCode>
-                <c:ptCount val="19"/>
+                <c:ptCount val="20"/>
                 <c:pt idx="0">
                   <c:v>0</c:v>
                 </c:pt>
@@ -1218,14 +1245,14 @@
                   <c:v>0</c:v>
                 </c:pt>
                 <c:pt idx="3">
+                  <c:v>0</c:v>
+                </c:pt>
+                <c:pt idx="4">
                   <c:v>-0.112</c:v>
                 </c:pt>
-                <c:pt idx="4">
+                <c:pt idx="5">
                   <c:v>-0.105</c:v>
                 </c:pt>
-                <c:pt idx="5">
-                  <c:v>0</c:v>
-                </c:pt>
                 <c:pt idx="6">
                   <c:v>0</c:v>
                 </c:pt>
@@ -1242,17 +1269,17 @@
                   <c:v>0</c:v>
                 </c:pt>
                 <c:pt idx="11">
+                  <c:v>0</c:v>
+                </c:pt>
+                <c:pt idx="12">
                   <c:v>-0.06</c:v>
                 </c:pt>
-                <c:pt idx="12">
-                  <c:v>0</c:v>
-                </c:pt>
                 <c:pt idx="13">
+                  <c:v>0</c:v>
+                </c:pt>
+                <c:pt idx="14">
                   <c:v>-0.031</c:v>
                 </c:pt>
-                <c:pt idx="14">
-                  <c:v>0</c:v>
-                </c:pt>
                 <c:pt idx="15">
                   <c:v>0</c:v>
                 </c:pt>
@@ -1263,6 +1290,9 @@
                   <c:v>0</c:v>
                 </c:pt>
                 <c:pt idx="18">
+                  <c:v>0</c:v>
+                </c:pt>
+                <c:pt idx="19">
                   <c:v>0</c:v>
                 </c:pt>
               </c:numCache>
@@ -1531,9 +1561,9 @@
           </c:dLbls>
           <c:cat>
             <c:multiLvlStrRef>
-              <c:f>Sheet1!$A$2:$A$21</c:f>
+              <c:f>Sheet1!$A$2:$A$22</c:f>
               <c:multiLvlStrCache>
-                <c:ptCount val="20"/>
+                <c:ptCount val="21"/>
                 <c:lvl>
                   <c:pt idx="0">
                     <c:v>DPEPO</c:v>
@@ -1575,24 +1605,27 @@
                     <c:v>HATCN</c:v>
                   </c:pt>
                   <c:pt idx="13">
+                    <c:v>Cs₂CO₃</c:v>
+                  </c:pt>
+                  <c:pt idx="14">
                     <c:v>3TPYMB</c:v>
                   </c:pt>
-                  <c:pt idx="14">
+                  <c:pt idx="15">
                     <c:v>TmPyPB</c:v>
                   </c:pt>
-                  <c:pt idx="15">
+                  <c:pt idx="16">
                     <c:v>Liq</c:v>
                   </c:pt>
-                  <c:pt idx="16">
+                  <c:pt idx="17">
                     <c:v>NPB</c:v>
                   </c:pt>
-                  <c:pt idx="17">
+                  <c:pt idx="18">
                     <c:v>TSPO1</c:v>
                   </c:pt>
-                  <c:pt idx="18">
+                  <c:pt idx="19">
                     <c:v>mCP</c:v>
                   </c:pt>
-                  <c:pt idx="19">
+                  <c:pt idx="20">
                     <c:v>MoOx (ref.)</c:v>
                   </c:pt>
                 </c:lvl>
@@ -1601,10 +1634,10 @@
           </c:cat>
           <c:val>
             <c:numRef>
-              <c:f>Sheet1!$B$2:$B$21</c:f>
+              <c:f>Sheet1!$B$2:$B$22</c:f>
               <c:numCache>
                 <c:formatCode>General</c:formatCode>
-                <c:ptCount val="20"/>
+                <c:ptCount val="21"/>
                 <c:pt idx="0">
                   <c:v>0</c:v>
                 </c:pt>
@@ -1663,6 +1696,9 @@
                   <c:v>0</c:v>
                 </c:pt>
                 <c:pt idx="19">
+                  <c:v>0</c:v>
+                </c:pt>
+                <c:pt idx="20">
                   <c:v>0</c:v>
                 </c:pt>
               </c:numCache>
@@ -1716,9 +1752,9 @@
           </c:dLbls>
           <c:cat>
             <c:multiLvlStrRef>
-              <c:f>Sheet1!$A$2:$A$21</c:f>
+              <c:f>Sheet1!$A$2:$A$22</c:f>
               <c:multiLvlStrCache>
-                <c:ptCount val="20"/>
+                <c:ptCount val="21"/>
                 <c:lvl>
                   <c:pt idx="0">
                     <c:v>DPEPO</c:v>
@@ -1760,24 +1796,27 @@
                     <c:v>HATCN</c:v>
                   </c:pt>
                   <c:pt idx="13">
+                    <c:v>Cs₂CO₃</c:v>
+                  </c:pt>
+                  <c:pt idx="14">
                     <c:v>3TPYMB</c:v>
                   </c:pt>
-                  <c:pt idx="14">
+                  <c:pt idx="15">
                     <c:v>TmPyPB</c:v>
                   </c:pt>
-                  <c:pt idx="15">
+                  <c:pt idx="16">
                     <c:v>Liq</c:v>
                   </c:pt>
-                  <c:pt idx="16">
+                  <c:pt idx="17">
                     <c:v>NPB</c:v>
                   </c:pt>
-                  <c:pt idx="17">
+                  <c:pt idx="18">
                     <c:v>TSPO1</c:v>
                   </c:pt>
-                  <c:pt idx="18">
+                  <c:pt idx="19">
                     <c:v>mCP</c:v>
                   </c:pt>
-                  <c:pt idx="19">
+                  <c:pt idx="20">
                     <c:v>MoOx (ref.)</c:v>
                   </c:pt>
                 </c:lvl>
@@ -1786,10 +1825,10 @@
           </c:cat>
           <c:val>
             <c:numRef>
-              <c:f>Sheet1!$C$2:$C$21</c:f>
+              <c:f>Sheet1!$C$2:$C$22</c:f>
               <c:numCache>
                 <c:formatCode>General</c:formatCode>
-                <c:ptCount val="20"/>
+                <c:ptCount val="21"/>
                 <c:pt idx="0">
                   <c:v>0</c:v>
                 </c:pt>
@@ -1830,17 +1869,17 @@
                   <c:v>0</c:v>
                 </c:pt>
                 <c:pt idx="13">
+                  <c:v>-0.138</c:v>
+                </c:pt>
+                <c:pt idx="14">
                   <c:v>-0.131</c:v>
                 </c:pt>
-                <c:pt idx="14">
+                <c:pt idx="15">
                   <c:v>-0.112</c:v>
                 </c:pt>
-                <c:pt idx="15">
+                <c:pt idx="16">
                   <c:v>-0.07</c:v>
                 </c:pt>
-                <c:pt idx="16">
-                  <c:v>0</c:v>
-                </c:pt>
                 <c:pt idx="17">
                   <c:v>0</c:v>
                 </c:pt>
@@ -1848,6 +1887,9 @@
                   <c:v>0</c:v>
                 </c:pt>
                 <c:pt idx="19">
+                  <c:v>0</c:v>
+                </c:pt>
+                <c:pt idx="20">
                   <c:v>0</c:v>
                 </c:pt>
               </c:numCache>
@@ -1901,9 +1943,9 @@
           </c:dLbls>
           <c:cat>
             <c:multiLvlStrRef>
-              <c:f>Sheet1!$A$2:$A$21</c:f>
+              <c:f>Sheet1!$A$2:$A$22</c:f>
               <c:multiLvlStrCache>
-                <c:ptCount val="20"/>
+                <c:ptCount val="21"/>
                 <c:lvl>
                   <c:pt idx="0">
                     <c:v>DPEPO</c:v>
@@ -1945,24 +1987,27 @@
                     <c:v>HATCN</c:v>
                   </c:pt>
                   <c:pt idx="13">
+                    <c:v>Cs₂CO₃</c:v>
+                  </c:pt>
+                  <c:pt idx="14">
                     <c:v>3TPYMB</c:v>
                   </c:pt>
-                  <c:pt idx="14">
+                  <c:pt idx="15">
                     <c:v>TmPyPB</c:v>
                   </c:pt>
-                  <c:pt idx="15">
+                  <c:pt idx="16">
                     <c:v>Liq</c:v>
                   </c:pt>
-                  <c:pt idx="16">
+                  <c:pt idx="17">
                     <c:v>NPB</c:v>
                   </c:pt>
-                  <c:pt idx="17">
+                  <c:pt idx="18">
                     <c:v>TSPO1</c:v>
                   </c:pt>
-                  <c:pt idx="18">
+                  <c:pt idx="19">
                     <c:v>mCP</c:v>
                   </c:pt>
-                  <c:pt idx="19">
+                  <c:pt idx="20">
                     <c:v>MoOx (ref.)</c:v>
                   </c:pt>
                 </c:lvl>
@@ -1971,10 +2016,10 @@
           </c:cat>
           <c:val>
             <c:numRef>
-              <c:f>Sheet1!$D$2:$D$21</c:f>
+              <c:f>Sheet1!$D$2:$D$22</c:f>
               <c:numCache>
                 <c:formatCode>General</c:formatCode>
-                <c:ptCount val="20"/>
+                <c:ptCount val="21"/>
                 <c:pt idx="0">
                   <c:v>-0.505</c:v>
                 </c:pt>
@@ -2024,15 +2069,18 @@
                   <c:v>0</c:v>
                 </c:pt>
                 <c:pt idx="16">
+                  <c:v>0</c:v>
+                </c:pt>
+                <c:pt idx="17">
                   <c:v>-0.018</c:v>
                 </c:pt>
-                <c:pt idx="17">
+                <c:pt idx="18">
                   <c:v>-0.017</c:v>
                 </c:pt>
-                <c:pt idx="18">
+                <c:pt idx="19">
                   <c:v>0.008</c:v>
                 </c:pt>
-                <c:pt idx="19">
+                <c:pt idx="20">
                   <c:v>0</c:v>
                 </c:pt>
               </c:numCache>
@@ -2086,9 +2134,9 @@
           </c:dLbls>
           <c:cat>
             <c:multiLvlStrRef>
-              <c:f>Sheet1!$A$2:$A$21</c:f>
+              <c:f>Sheet1!$A$2:$A$22</c:f>
               <c:multiLvlStrCache>
-                <c:ptCount val="20"/>
+                <c:ptCount val="21"/>
                 <c:lvl>
                   <c:pt idx="0">
                     <c:v>DPEPO</c:v>
@@ -2130,24 +2178,27 @@
                     <c:v>HATCN</c:v>
                   </c:pt>
                   <c:pt idx="13">
+                    <c:v>Cs₂CO₃</c:v>
+                  </c:pt>
+                  <c:pt idx="14">
                     <c:v>3TPYMB</c:v>
                   </c:pt>
-                  <c:pt idx="14">
+                  <c:pt idx="15">
                     <c:v>TmPyPB</c:v>
                   </c:pt>
-                  <c:pt idx="15">
+                  <c:pt idx="16">
                     <c:v>Liq</c:v>
                   </c:pt>
-                  <c:pt idx="16">
+                  <c:pt idx="17">
                     <c:v>NPB</c:v>
                   </c:pt>
-                  <c:pt idx="17">
+                  <c:pt idx="18">
                     <c:v>TSPO1</c:v>
                   </c:pt>
-                  <c:pt idx="18">
+                  <c:pt idx="19">
                     <c:v>mCP</c:v>
                   </c:pt>
-                  <c:pt idx="19">
+                  <c:pt idx="20">
                     <c:v>MoOx (ref.)</c:v>
                   </c:pt>
                 </c:lvl>
@@ -2156,10 +2207,10 @@
           </c:cat>
           <c:val>
             <c:numRef>
-              <c:f>Sheet1!$E$2:$E$21</c:f>
+              <c:f>Sheet1!$E$2:$E$22</c:f>
               <c:numCache>
                 <c:formatCode>General</c:formatCode>
-                <c:ptCount val="20"/>
+                <c:ptCount val="21"/>
                 <c:pt idx="0">
                   <c:v>0</c:v>
                 </c:pt>
@@ -2218,6 +2269,9 @@
                   <c:v>0</c:v>
                 </c:pt>
                 <c:pt idx="19">
+                  <c:v>0</c:v>
+                </c:pt>
+                <c:pt idx="20">
                   <c:v>0.456</c:v>
                 </c:pt>
               </c:numCache>
@@ -5602,7 +5656,7 @@
                 <a:ea typeface="Malgun Gothic" pitchFamily="34" charset="-122"/>
                 <a:cs typeface="Malgun Gothic" pitchFamily="34" charset="-120"/>
               </a:rPr>
-              <a:t>유기물 19종 · E_b, q(Ag₁): PBE0-D3/def2-SVP · Δq: GFN2-xTB · MoOx는 참고값</a:t>
+              <a:t>유기물 19종 + Cs₂CO₃ · E_b, q(Ag₁): PBE0-D3/def2-SVP · Δq: GFN2-xTB · MoOx는 참고값</a:t>
             </a:r>
             <a:endParaRPr lang="en-US" sz="1300" dirty="0"/>
           </a:p>
@@ -5719,7 +5773,7 @@
                 <a:ea typeface="Malgun Gothic" pitchFamily="34" charset="-122"/>
                 <a:cs typeface="Malgun Gothic" pitchFamily="34" charset="-120"/>
               </a:rPr>
-              <a:t>0.5 eV 통과: HIL 3종 + phen 킬레이트 2종뿐. PO-T2T는 대부분 분산력, BCP는 화학 결합</a:t>
+              <a:t>0.5 eV 통과: HIL 3종 + phen 킬레이트 2종 + Cs₂CO₃. PO-T2T는 대부분 분산력, BCP는 화학 결합</a:t>
             </a:r>
             <a:endParaRPr lang="en-US" sz="1050" dirty="0"/>
           </a:p>
@@ -5891,7 +5945,7 @@
                 <a:ea typeface="Malgun Gothic" pitchFamily="34" charset="-122"/>
                 <a:cs typeface="Malgun Gothic" pitchFamily="34" charset="-120"/>
               </a:rPr>
-              <a:t>유기물 19종 모두 통과(≤ 0: 전하를 되돌려 Ag₂ 금속). MoOx만 +0.46으로 탈락</a:t>
+              <a:t>유기물 19종과 Cs₂CO₃ 모두 통과(≤ 0: Ag₂ 금속). MoOx만 +0.46으로 탈락</a:t>
             </a:r>
             <a:endParaRPr lang="en-US" sz="1050" dirty="0"/>
           </a:p>

</xml_diff>